<commit_message>
Add football-app style Matches/Players pages, club crests and custom dropdowns
- Matches: every Premier League match by matchweek plus FA Cup, League Cup,
  Champions League and Europa League rounds; league tables with form; a
  slide-in match centre (stats, line-ups on a pitch, form, Elo, head-to-head,
  the model's prediction), team and player pages
- Players: every FPL player since 2016-17 with search, filters and sorting
- Real club crests from luukhopman/football-logos (coloured badge fallback)
- Styled dropdowns replace the native select menus
- Report and slides describe the website; tests for the new endpoints

Co-Authored-By: Claude Opus 5.5 <noreply@anthropic.com>
Claude-Session: https://claude.ai/code/session_018HoHzK2ge6crgk6i9xHghG
</commit_message>
<xml_diff>
--- a/docs/slides.pptx
+++ b/docs/slides.pptx
@@ -23,9 +23,10 @@
     <p:sldId id="271" r:id="rId17"/>
     <p:sldId id="272" r:id="rId18"/>
     <p:sldId id="273" r:id="rId19"/>
+    <p:sldId id="274" r:id="rId20"/>
   </p:sldIdLst>
   <p:notesMasterIdLst>
-    <p:notesMasterId r:id="rId20"/>
+    <p:notesMasterId r:id="rId21"/>
   </p:notesMasterIdLst>
   <p:sldSz cx="12192000" cy="6858000"/>
   <p:notesSz cx="6858000" cy="12192000"/>
@@ -3809,7 +3810,7 @@
           <a:p>
             <a:r>
               <a:rPr lang="en-US" dirty="0"/>
-              <a:t>Our model does not know about injuries or the confirmed line-up, which is the biggest reason the bookmaker is still slightly better. Draws stay very hard. Some data is missing from free sources. Next we would add expected-goals data and simulate whole seasons to predict the final table.</a:t>
+              <a:t>Everything in this presentation can be checked on our website. The Predict page shows the calculation for any fixture. The Matches page works like a football app: every Premier League, cup and European match with its statistics, the line-ups on a pitch and what our model predicted before kick-off. There are pages for players and teams, all the raw data row by row, and the full evaluation.</a:t>
             </a:r>
             <a:endParaRPr lang="en-US" dirty="0"/>
           </a:p>
@@ -3897,7 +3898,7 @@
           <a:p>
             <a:r>
               <a:rPr lang="en-US" dirty="0"/>
-              <a:t>To conclude: with real data and a fair test, our model predicts Premier League results about as well as we could expect, within about one percentage point of a professional bookmaker. Team strength is the most important information, and a simple model beat the complex ones. Most of all, we learned that testing honestly matters more than using a fancy model. Thank you, we are happy to take questions, and we can show the live website.</a:t>
+              <a:t>Our model does not know about injuries or the confirmed line-up, which is the biggest reason the bookmaker is still slightly better. Draws stay very hard. Some data is missing from free sources. Next we would add expected-goals data and simulate whole seasons to predict the final table.</a:t>
             </a:r>
             <a:endParaRPr lang="en-US" dirty="0"/>
           </a:p>
@@ -3985,7 +3986,7 @@
           <a:p>
             <a:r>
               <a:rPr lang="en-US" dirty="0"/>
-              <a:t>All sources and references are listed here and in SOURCES.md, with full citations.</a:t>
+              <a:t>To conclude: with real data and a fair test, our model predicts Premier League results about as well as we could expect, within about one percentage point of a professional bookmaker. Team strength is the most important information, and a simple model beat the complex ones. Most of all, we learned that testing honestly matters more than using a fancy model. Thank you, we are happy to take questions, and we can show the live website.</a:t>
             </a:r>
             <a:endParaRPr lang="en-US" dirty="0"/>
           </a:p>
@@ -4009,6 +4010,94 @@
             <a:fld id="{F7021451-1387-4CA6-816F-3879F97B5CBC}" type="slidenum">
               <a:rPr lang="en-US"/>
               <a:t>18</a:t>
+            </a:fld>
+            <a:endParaRPr lang="en-US"/>
+          </a:p>
+        </p:txBody>
+      </p:sp>
+    </p:spTree>
+    <p:extLst>
+      <p:ext uri="{BB962C8B-B14F-4D97-AF65-F5344CB8AC3E}">
+        <p14:creationId xmlns:p14="http://schemas.microsoft.com/office/powerpoint/2010/main" val="1024086991"/>
+      </p:ext>
+    </p:extLst>
+  </p:cSld>
+  <p:clrMapOvr>
+    <a:masterClrMapping/>
+  </p:clrMapOvr>
+</p:notes>
+</file>
+
+<file path=ppt/notesSlides/notesSlide19.xml><?xml version="1.0" encoding="utf-8"?>
+<p:notes xmlns:a="http://schemas.openxmlformats.org/drawingml/2006/main" xmlns:r="http://schemas.openxmlformats.org/officeDocument/2006/relationships" xmlns:p="http://schemas.openxmlformats.org/presentationml/2006/main">
+  <p:cSld>
+    <p:spTree>
+      <p:nvGrpSpPr>
+        <p:cNvPr id="1" name=""/>
+        <p:cNvGrpSpPr/>
+        <p:nvPr/>
+      </p:nvGrpSpPr>
+      <p:grpSpPr>
+        <a:xfrm>
+          <a:off x="0" y="0"/>
+          <a:ext cx="0" cy="0"/>
+          <a:chOff x="0" y="0"/>
+          <a:chExt cx="0" cy="0"/>
+        </a:xfrm>
+      </p:grpSpPr>
+      <p:sp>
+        <p:nvSpPr>
+          <p:cNvPr id="2" name="Slide Image Placeholder 1"/>
+          <p:cNvSpPr>
+            <a:spLocks noGrp="1" noRot="1" noChangeAspect="1"/>
+          </p:cNvSpPr>
+          <p:nvPr>
+            <p:ph type="sldImg"/>
+          </p:nvPr>
+        </p:nvSpPr>
+        <p:spPr/>
+      </p:sp>
+      <p:sp>
+        <p:nvSpPr>
+          <p:cNvPr id="3" name="Notes Placeholder 2"/>
+          <p:cNvSpPr>
+            <a:spLocks noGrp="1"/>
+          </p:cNvSpPr>
+          <p:nvPr>
+            <p:ph type="body" idx="1"/>
+          </p:nvPr>
+        </p:nvSpPr>
+        <p:spPr/>
+        <p:txBody>
+          <a:bodyPr/>
+          <a:lstStyle/>
+          <a:p>
+            <a:r>
+              <a:rPr lang="en-US" dirty="0"/>
+              <a:t>All sources and references are listed here and in SOURCES.md, with full citations.</a:t>
+            </a:r>
+            <a:endParaRPr lang="en-US" dirty="0"/>
+          </a:p>
+        </p:txBody>
+      </p:sp>
+      <p:sp>
+        <p:nvSpPr>
+          <p:cNvPr id="4" name="Slide Number Placeholder 3"/>
+          <p:cNvSpPr>
+            <a:spLocks noGrp="1"/>
+          </p:cNvSpPr>
+          <p:nvPr>
+            <p:ph type="sldNum" sz="quarter" idx="10"/>
+          </p:nvPr>
+        </p:nvSpPr>
+        <p:spPr/>
+        <p:txBody>
+          <a:bodyPr/>
+          <a:lstStyle/>
+          <a:p>
+            <a:fld id="{F7021451-1387-4CA6-816F-3879F97B5CBC}" type="slidenum">
+              <a:rPr lang="en-US"/>
+              <a:t>19</a:t>
             </a:fld>
             <a:endParaRPr lang="en-US"/>
           </a:p>
@@ -10059,7 +10148,7 @@
                   <a:srgbClr val="0071E3"/>
                 </a:solidFill>
               </a:rPr>
-              <a:t>Limitations</a:t>
+              <a:t>Website</a:t>
             </a:r>
             <a:endParaRPr lang="en-US" sz="1600" dirty="0"/>
           </a:p>
@@ -10097,7 +10186,7 @@
                   <a:srgbClr val="1D1D1F"/>
                 </a:solidFill>
               </a:rPr>
-              <a:t>What could be better</a:t>
+              <a:t>Everything can be checked on our website</a:t>
             </a:r>
             <a:endParaRPr lang="en-US" sz="3600" dirty="0"/>
           </a:p>
@@ -10230,7 +10319,7 @@
                   <a:srgbClr val="1D1D1F"/>
                 </a:solidFill>
               </a:rPr>
-              <a:t>Team news</a:t>
+              <a:t>Predict</a:t>
             </a:r>
             <a:endParaRPr lang="en-US" sz="1900" dirty="0"/>
           </a:p>
@@ -10266,7 +10355,7 @@
                   <a:srgbClr val="6E6E73"/>
                 </a:solidFill>
               </a:rPr>
-              <a:t>Injuries and confirmed line-ups: the main reason bookmakers are better</a:t>
+              <a:t>Any fixture, with every step of the calculation shown</a:t>
             </a:r>
             <a:endParaRPr lang="en-US" sz="1500" dirty="0"/>
           </a:p>
@@ -10399,7 +10488,7 @@
                   <a:srgbClr val="1D1D1F"/>
                 </a:solidFill>
               </a:rPr>
-              <a:t>Draws</a:t>
+              <a:t>Matches</a:t>
             </a:r>
             <a:endParaRPr lang="en-US" sz="1900" dirty="0"/>
           </a:p>
@@ -10435,7 +10524,7 @@
                   <a:srgbClr val="6E6E73"/>
                 </a:solidFill>
               </a:rPr>
-              <a:t>Still almost impossible to pick</a:t>
+              <a:t>Every league, cup and European match: stats, line-ups, our prediction</a:t>
             </a:r>
             <a:endParaRPr lang="en-US" sz="1500" dirty="0"/>
           </a:p>
@@ -10568,7 +10657,7 @@
                   <a:srgbClr val="1D1D1F"/>
                 </a:solidFill>
               </a:rPr>
-              <a:t>Missing data</a:t>
+              <a:t>Players and teams</a:t>
             </a:r>
             <a:endParaRPr lang="en-US" sz="1900" dirty="0"/>
           </a:p>
@@ -10604,7 +10693,7 @@
                   <a:srgbClr val="6E6E73"/>
                 </a:solidFill>
               </a:rPr>
-              <a:t>Europa League before 2020-21, managers not yet included</a:t>
+              <a:t>Season stats, form, Elo and top players for every club</a:t>
             </a:r>
             <a:endParaRPr lang="en-US" sz="1500" dirty="0"/>
           </a:p>
@@ -10737,7 +10826,7 @@
                   <a:srgbClr val="1D1D1F"/>
                 </a:solidFill>
               </a:rPr>
-              <a:t>Next steps</a:t>
+              <a:t>Data and evaluation</a:t>
             </a:r>
             <a:endParaRPr lang="en-US" sz="1900" dirty="0"/>
           </a:p>
@@ -10773,7 +10862,7 @@
                   <a:srgbClr val="6E6E73"/>
                 </a:solidFill>
               </a:rPr>
-              <a:t>Expected goals (xG) data, simulating a whole season's table</a:t>
+              <a:t>Every row of every source, and every accuracy measure</a:t>
             </a:r>
             <a:endParaRPr lang="en-US" sz="1500" dirty="0"/>
           </a:p>
@@ -10857,7 +10946,7 @@
         </p:nvSpPr>
         <p:spPr>
           <a:xfrm>
-            <a:off x="548640" y="822960"/>
+            <a:off x="548640" y="502920"/>
             <a:ext cx="11094415" cy="365760"/>
           </a:xfrm>
           <a:prstGeom prst="rect">
@@ -10876,10 +10965,10 @@
             <a:r>
               <a:rPr lang="en-US" sz="1600" b="1" dirty="0">
                 <a:solidFill>
-                  <a:srgbClr val="2997FF"/>
+                  <a:srgbClr val="0071E3"/>
                 </a:solidFill>
               </a:rPr>
-              <a:t>Conclusion</a:t>
+              <a:t>Limitations</a:t>
             </a:r>
             <a:endParaRPr lang="en-US" sz="1600" dirty="0"/>
           </a:p>
@@ -10893,7 +10982,7 @@
         </p:nvSpPr>
         <p:spPr>
           <a:xfrm>
-            <a:off x="548640" y="1207008"/>
+            <a:off x="548640" y="886968"/>
             <a:ext cx="11094415" cy="868680"/>
           </a:xfrm>
           <a:prstGeom prst="rect">
@@ -10914,10 +11003,10 @@
             <a:r>
               <a:rPr lang="en-US" sz="3600" b="1" dirty="0">
                 <a:solidFill>
-                  <a:srgbClr val="FFFFFF"/>
+                  <a:srgbClr val="1D1D1F"/>
                 </a:solidFill>
               </a:rPr>
-              <a:t>What we learned</a:t>
+              <a:t>What could be better</a:t>
             </a:r>
             <a:endParaRPr lang="en-US" sz="3600" dirty="0"/>
           </a:p>
@@ -10925,39 +11014,73 @@
       </p:sp>
       <p:sp>
         <p:nvSpPr>
-          <p:cNvPr id="5" name="Number 1"/>
+          <p:cNvPr id="5" name="Card 1"/>
           <p:cNvSpPr/>
           <p:nvPr/>
         </p:nvSpPr>
         <p:spPr>
           <a:xfrm>
-            <a:off x="548640" y="2377440"/>
-            <a:ext cx="548640" cy="548640"/>
-          </a:xfrm>
-          <a:prstGeom prst="ellipse">
-            <a:avLst/>
+            <a:off x="548640" y="1965960"/>
+            <a:ext cx="5410048" cy="1965960"/>
+          </a:xfrm>
+          <a:prstGeom prst="roundRect">
+            <a:avLst>
+              <a:gd name="adj" fmla="val 8372"/>
+            </a:avLst>
           </a:prstGeom>
           <a:solidFill>
-            <a:srgbClr val="2997FF"/>
+            <a:srgbClr val="FFFFFF"/>
           </a:solidFill>
           <a:ln w="12700">
             <a:solidFill>
-              <a:srgbClr val="2997FF"/>
+              <a:srgbClr val="FFFFFF"/>
             </a:solidFill>
             <a:prstDash val="solid"/>
           </a:ln>
-        </p:spPr>
-      </p:sp>
-      <p:sp>
-        <p:nvSpPr>
-          <p:cNvPr id="6" name="Text 3"/>
+          <a:effectLst>
+            <a:outerShdw sx="100000" sy="100000" kx="0" ky="0" algn="bl" rotWithShape="0" blurRad="101600" dist="25400" dir="5400000">
+              <a:srgbClr val="000000">
+                <a:alpha val="8000"/>
+              </a:srgbClr>
+            </a:outerShdw>
+          </a:effectLst>
+        </p:spPr>
+      </p:sp>
+      <p:sp>
+        <p:nvSpPr>
+          <p:cNvPr id="6" name="Card 1 dot"/>
+          <p:cNvSpPr/>
+          <p:nvPr/>
+        </p:nvSpPr>
+        <p:spPr>
+          <a:xfrm>
+            <a:off x="822960" y="2240280"/>
+            <a:ext cx="384048" cy="384048"/>
+          </a:xfrm>
+          <a:prstGeom prst="ellipse">
+            <a:avLst/>
+          </a:prstGeom>
+          <a:solidFill>
+            <a:srgbClr val="0071E3"/>
+          </a:solidFill>
+          <a:ln w="12700">
+            <a:solidFill>
+              <a:srgbClr val="0071E3"/>
+            </a:solidFill>
+            <a:prstDash val="solid"/>
+          </a:ln>
+        </p:spPr>
+      </p:sp>
+      <p:sp>
+        <p:nvSpPr>
+          <p:cNvPr id="7" name="Text 4"/>
           <p:cNvSpPr txBox="1"/>
           <p:nvPr/>
         </p:nvSpPr>
         <p:spPr>
           <a:xfrm>
-            <a:off x="548640" y="2377440"/>
-            <a:ext cx="548640" cy="548640"/>
+            <a:off x="822960" y="2240280"/>
+            <a:ext cx="384048" cy="384048"/>
           </a:xfrm>
           <a:prstGeom prst="rect">
             <a:avLst/>
@@ -10973,27 +11096,27 @@
               <a:buNone/>
             </a:pPr>
             <a:r>
-              <a:rPr lang="en-US" sz="2000" b="1" dirty="0">
-                <a:solidFill>
-                  <a:srgbClr val="000000"/>
+              <a:rPr lang="en-US" sz="1400" b="1" dirty="0">
+                <a:solidFill>
+                  <a:srgbClr val="FFFFFF"/>
                 </a:solidFill>
               </a:rPr>
               <a:t>1</a:t>
             </a:r>
-            <a:endParaRPr lang="en-US" sz="2000" dirty="0"/>
-          </a:p>
-        </p:txBody>
-      </p:sp>
-      <p:sp>
-        <p:nvSpPr>
-          <p:cNvPr id="7" name="Takeaway 1"/>
+            <a:endParaRPr lang="en-US" sz="1400" dirty="0"/>
+          </a:p>
+        </p:txBody>
+      </p:sp>
+      <p:sp>
+        <p:nvSpPr>
+          <p:cNvPr id="8" name="Text 5"/>
           <p:cNvSpPr txBox="1"/>
           <p:nvPr/>
         </p:nvSpPr>
         <p:spPr>
           <a:xfrm>
-            <a:off x="1371600" y="2331720"/>
-            <a:ext cx="10271455" cy="640080"/>
+            <a:off x="1371600" y="2203704"/>
+            <a:ext cx="4312768" cy="457200"/>
           </a:xfrm>
           <a:prstGeom prst="rect">
             <a:avLst/>
@@ -11002,59 +11125,131 @@
           <a:ln/>
         </p:spPr>
         <p:txBody>
-          <a:bodyPr wrap="square" lIns="0" tIns="0" rIns="0" bIns="0" rtlCol="0" anchor="ctr"/>
+          <a:bodyPr wrap="square" lIns="0" tIns="0" rIns="0" bIns="0" rtlCol="0" anchor="ctr">
+            <a:normAutofit/>
+          </a:bodyPr>
           <a:lstStyle/>
           <a:p>
             <a:pPr indent="0" marL="0">
               <a:buNone/>
             </a:pPr>
             <a:r>
-              <a:rPr lang="en-US" sz="2400" dirty="0">
-                <a:solidFill>
-                  <a:srgbClr val="FFFFFF"/>
+              <a:rPr lang="en-US" sz="1900" b="1" dirty="0">
+                <a:solidFill>
+                  <a:srgbClr val="1D1D1F"/>
                 </a:solidFill>
               </a:rPr>
-              <a:t>A fair model reaches 53.6%, close to the bookmaker's 54.7%</a:t>
-            </a:r>
-            <a:endParaRPr lang="en-US" sz="2400" dirty="0"/>
-          </a:p>
-        </p:txBody>
-      </p:sp>
-      <p:sp>
-        <p:nvSpPr>
-          <p:cNvPr id="8" name="Number 2"/>
+              <a:t>Team news</a:t>
+            </a:r>
+            <a:endParaRPr lang="en-US" sz="1900" dirty="0"/>
+          </a:p>
+        </p:txBody>
+      </p:sp>
+      <p:sp>
+        <p:nvSpPr>
+          <p:cNvPr id="9" name="Text 6"/>
+          <p:cNvSpPr txBox="1"/>
+          <p:nvPr/>
+        </p:nvSpPr>
+        <p:spPr>
+          <a:xfrm>
+            <a:off x="822960" y="2770632"/>
+            <a:ext cx="4861408" cy="1005840"/>
+          </a:xfrm>
+          <a:prstGeom prst="rect">
+            <a:avLst/>
+          </a:prstGeom>
+          <a:noFill/>
+          <a:ln/>
+        </p:spPr>
+        <p:txBody>
+          <a:bodyPr wrap="square" lIns="0" tIns="0" rIns="0" bIns="0" rtlCol="0" anchor="t"/>
+          <a:lstStyle/>
+          <a:p>
+            <a:pPr indent="0" marL="0">
+              <a:buNone/>
+            </a:pPr>
+            <a:r>
+              <a:rPr lang="en-US" sz="1500" dirty="0">
+                <a:solidFill>
+                  <a:srgbClr val="6E6E73"/>
+                </a:solidFill>
+              </a:rPr>
+              <a:t>Injuries and confirmed line-ups: the main reason bookmakers are better</a:t>
+            </a:r>
+            <a:endParaRPr lang="en-US" sz="1500" dirty="0"/>
+          </a:p>
+        </p:txBody>
+      </p:sp>
+      <p:sp>
+        <p:nvSpPr>
+          <p:cNvPr id="10" name="Card 2"/>
           <p:cNvSpPr/>
           <p:nvPr/>
         </p:nvSpPr>
         <p:spPr>
           <a:xfrm>
-            <a:off x="548640" y="3520440"/>
-            <a:ext cx="548640" cy="548640"/>
-          </a:xfrm>
-          <a:prstGeom prst="ellipse">
-            <a:avLst/>
+            <a:off x="6233008" y="1965960"/>
+            <a:ext cx="5410048" cy="1965960"/>
+          </a:xfrm>
+          <a:prstGeom prst="roundRect">
+            <a:avLst>
+              <a:gd name="adj" fmla="val 8372"/>
+            </a:avLst>
           </a:prstGeom>
           <a:solidFill>
-            <a:srgbClr val="2997FF"/>
+            <a:srgbClr val="FFFFFF"/>
           </a:solidFill>
           <a:ln w="12700">
             <a:solidFill>
-              <a:srgbClr val="2997FF"/>
+              <a:srgbClr val="FFFFFF"/>
             </a:solidFill>
             <a:prstDash val="solid"/>
           </a:ln>
-        </p:spPr>
-      </p:sp>
-      <p:sp>
-        <p:nvSpPr>
-          <p:cNvPr id="9" name="Text 6"/>
+          <a:effectLst>
+            <a:outerShdw sx="100000" sy="100000" kx="0" ky="0" algn="bl" rotWithShape="0" blurRad="101600" dist="25400" dir="5400000">
+              <a:srgbClr val="000000">
+                <a:alpha val="8000"/>
+              </a:srgbClr>
+            </a:outerShdw>
+          </a:effectLst>
+        </p:spPr>
+      </p:sp>
+      <p:sp>
+        <p:nvSpPr>
+          <p:cNvPr id="11" name="Card 2 dot"/>
+          <p:cNvSpPr/>
+          <p:nvPr/>
+        </p:nvSpPr>
+        <p:spPr>
+          <a:xfrm>
+            <a:off x="6507328" y="2240280"/>
+            <a:ext cx="384048" cy="384048"/>
+          </a:xfrm>
+          <a:prstGeom prst="ellipse">
+            <a:avLst/>
+          </a:prstGeom>
+          <a:solidFill>
+            <a:srgbClr val="0071E3"/>
+          </a:solidFill>
+          <a:ln w="12700">
+            <a:solidFill>
+              <a:srgbClr val="0071E3"/>
+            </a:solidFill>
+            <a:prstDash val="solid"/>
+          </a:ln>
+        </p:spPr>
+      </p:sp>
+      <p:sp>
+        <p:nvSpPr>
+          <p:cNvPr id="12" name="Text 9"/>
           <p:cNvSpPr txBox="1"/>
           <p:nvPr/>
         </p:nvSpPr>
         <p:spPr>
           <a:xfrm>
-            <a:off x="548640" y="3520440"/>
-            <a:ext cx="548640" cy="548640"/>
+            <a:off x="6507328" y="2240280"/>
+            <a:ext cx="384048" cy="384048"/>
           </a:xfrm>
           <a:prstGeom prst="rect">
             <a:avLst/>
@@ -11070,27 +11265,27 @@
               <a:buNone/>
             </a:pPr>
             <a:r>
-              <a:rPr lang="en-US" sz="2000" b="1" dirty="0">
-                <a:solidFill>
-                  <a:srgbClr val="000000"/>
+              <a:rPr lang="en-US" sz="1400" b="1" dirty="0">
+                <a:solidFill>
+                  <a:srgbClr val="FFFFFF"/>
                 </a:solidFill>
               </a:rPr>
               <a:t>2</a:t>
             </a:r>
-            <a:endParaRPr lang="en-US" sz="2000" dirty="0"/>
-          </a:p>
-        </p:txBody>
-      </p:sp>
-      <p:sp>
-        <p:nvSpPr>
-          <p:cNvPr id="10" name="Takeaway 2"/>
+            <a:endParaRPr lang="en-US" sz="1400" dirty="0"/>
+          </a:p>
+        </p:txBody>
+      </p:sp>
+      <p:sp>
+        <p:nvSpPr>
+          <p:cNvPr id="13" name="Text 10"/>
           <p:cNvSpPr txBox="1"/>
           <p:nvPr/>
         </p:nvSpPr>
         <p:spPr>
           <a:xfrm>
-            <a:off x="1371600" y="3474720"/>
-            <a:ext cx="10271455" cy="640080"/>
+            <a:off x="7055968" y="2203704"/>
+            <a:ext cx="4312768" cy="457200"/>
           </a:xfrm>
           <a:prstGeom prst="rect">
             <a:avLst/>
@@ -11099,59 +11294,131 @@
           <a:ln/>
         </p:spPr>
         <p:txBody>
-          <a:bodyPr wrap="square" lIns="0" tIns="0" rIns="0" bIns="0" rtlCol="0" anchor="ctr"/>
+          <a:bodyPr wrap="square" lIns="0" tIns="0" rIns="0" bIns="0" rtlCol="0" anchor="ctr">
+            <a:normAutofit/>
+          </a:bodyPr>
           <a:lstStyle/>
           <a:p>
             <a:pPr indent="0" marL="0">
               <a:buNone/>
             </a:pPr>
             <a:r>
-              <a:rPr lang="en-US" sz="2400" dirty="0">
-                <a:solidFill>
-                  <a:srgbClr val="FFFFFF"/>
+              <a:rPr lang="en-US" sz="1900" b="1" dirty="0">
+                <a:solidFill>
+                  <a:srgbClr val="1D1D1F"/>
                 </a:solidFill>
               </a:rPr>
-              <a:t>Team strength (Elo) matters most; a simple Poisson model beat complex ones</a:t>
-            </a:r>
-            <a:endParaRPr lang="en-US" sz="2400" dirty="0"/>
-          </a:p>
-        </p:txBody>
-      </p:sp>
-      <p:sp>
-        <p:nvSpPr>
-          <p:cNvPr id="11" name="Number 3"/>
+              <a:t>Draws</a:t>
+            </a:r>
+            <a:endParaRPr lang="en-US" sz="1900" dirty="0"/>
+          </a:p>
+        </p:txBody>
+      </p:sp>
+      <p:sp>
+        <p:nvSpPr>
+          <p:cNvPr id="14" name="Text 11"/>
+          <p:cNvSpPr txBox="1"/>
+          <p:nvPr/>
+        </p:nvSpPr>
+        <p:spPr>
+          <a:xfrm>
+            <a:off x="6507328" y="2770632"/>
+            <a:ext cx="4861408" cy="1005840"/>
+          </a:xfrm>
+          <a:prstGeom prst="rect">
+            <a:avLst/>
+          </a:prstGeom>
+          <a:noFill/>
+          <a:ln/>
+        </p:spPr>
+        <p:txBody>
+          <a:bodyPr wrap="square" lIns="0" tIns="0" rIns="0" bIns="0" rtlCol="0" anchor="t"/>
+          <a:lstStyle/>
+          <a:p>
+            <a:pPr indent="0" marL="0">
+              <a:buNone/>
+            </a:pPr>
+            <a:r>
+              <a:rPr lang="en-US" sz="1500" dirty="0">
+                <a:solidFill>
+                  <a:srgbClr val="6E6E73"/>
+                </a:solidFill>
+              </a:rPr>
+              <a:t>Still almost impossible to pick</a:t>
+            </a:r>
+            <a:endParaRPr lang="en-US" sz="1500" dirty="0"/>
+          </a:p>
+        </p:txBody>
+      </p:sp>
+      <p:sp>
+        <p:nvSpPr>
+          <p:cNvPr id="15" name="Card 3"/>
           <p:cNvSpPr/>
           <p:nvPr/>
         </p:nvSpPr>
         <p:spPr>
           <a:xfrm>
-            <a:off x="548640" y="4663440"/>
-            <a:ext cx="548640" cy="548640"/>
-          </a:xfrm>
-          <a:prstGeom prst="ellipse">
-            <a:avLst/>
+            <a:off x="548640" y="4206240"/>
+            <a:ext cx="5410048" cy="1965960"/>
+          </a:xfrm>
+          <a:prstGeom prst="roundRect">
+            <a:avLst>
+              <a:gd name="adj" fmla="val 8372"/>
+            </a:avLst>
           </a:prstGeom>
           <a:solidFill>
-            <a:srgbClr val="2997FF"/>
+            <a:srgbClr val="FFFFFF"/>
           </a:solidFill>
           <a:ln w="12700">
             <a:solidFill>
-              <a:srgbClr val="2997FF"/>
+              <a:srgbClr val="FFFFFF"/>
             </a:solidFill>
             <a:prstDash val="solid"/>
           </a:ln>
-        </p:spPr>
-      </p:sp>
-      <p:sp>
-        <p:nvSpPr>
-          <p:cNvPr id="12" name="Text 9"/>
+          <a:effectLst>
+            <a:outerShdw sx="100000" sy="100000" kx="0" ky="0" algn="bl" rotWithShape="0" blurRad="101600" dist="25400" dir="5400000">
+              <a:srgbClr val="000000">
+                <a:alpha val="8000"/>
+              </a:srgbClr>
+            </a:outerShdw>
+          </a:effectLst>
+        </p:spPr>
+      </p:sp>
+      <p:sp>
+        <p:nvSpPr>
+          <p:cNvPr id="16" name="Card 3 dot"/>
+          <p:cNvSpPr/>
+          <p:nvPr/>
+        </p:nvSpPr>
+        <p:spPr>
+          <a:xfrm>
+            <a:off x="822960" y="4480560"/>
+            <a:ext cx="384048" cy="384048"/>
+          </a:xfrm>
+          <a:prstGeom prst="ellipse">
+            <a:avLst/>
+          </a:prstGeom>
+          <a:solidFill>
+            <a:srgbClr val="0071E3"/>
+          </a:solidFill>
+          <a:ln w="12700">
+            <a:solidFill>
+              <a:srgbClr val="0071E3"/>
+            </a:solidFill>
+            <a:prstDash val="solid"/>
+          </a:ln>
+        </p:spPr>
+      </p:sp>
+      <p:sp>
+        <p:nvSpPr>
+          <p:cNvPr id="17" name="Text 14"/>
           <p:cNvSpPr txBox="1"/>
           <p:nvPr/>
         </p:nvSpPr>
         <p:spPr>
           <a:xfrm>
-            <a:off x="548640" y="4663440"/>
-            <a:ext cx="548640" cy="548640"/>
+            <a:off x="822960" y="4480560"/>
+            <a:ext cx="384048" cy="384048"/>
           </a:xfrm>
           <a:prstGeom prst="rect">
             <a:avLst/>
@@ -11167,27 +11434,27 @@
               <a:buNone/>
             </a:pPr>
             <a:r>
-              <a:rPr lang="en-US" sz="2000" b="1" dirty="0">
-                <a:solidFill>
-                  <a:srgbClr val="000000"/>
+              <a:rPr lang="en-US" sz="1400" b="1" dirty="0">
+                <a:solidFill>
+                  <a:srgbClr val="FFFFFF"/>
                 </a:solidFill>
               </a:rPr>
               <a:t>3</a:t>
             </a:r>
-            <a:endParaRPr lang="en-US" sz="2000" dirty="0"/>
-          </a:p>
-        </p:txBody>
-      </p:sp>
-      <p:sp>
-        <p:nvSpPr>
-          <p:cNvPr id="13" name="Takeaway 3"/>
+            <a:endParaRPr lang="en-US" sz="1400" dirty="0"/>
+          </a:p>
+        </p:txBody>
+      </p:sp>
+      <p:sp>
+        <p:nvSpPr>
+          <p:cNvPr id="18" name="Text 15"/>
           <p:cNvSpPr txBox="1"/>
           <p:nvPr/>
         </p:nvSpPr>
         <p:spPr>
           <a:xfrm>
-            <a:off x="1371600" y="4617720"/>
-            <a:ext cx="10271455" cy="640080"/>
+            <a:off x="1371600" y="4443984"/>
+            <a:ext cx="4312768" cy="457200"/>
           </a:xfrm>
           <a:prstGeom prst="rect">
             <a:avLst/>
@@ -11196,21 +11463,228 @@
           <a:ln/>
         </p:spPr>
         <p:txBody>
-          <a:bodyPr wrap="square" lIns="0" tIns="0" rIns="0" bIns="0" rtlCol="0" anchor="ctr"/>
+          <a:bodyPr wrap="square" lIns="0" tIns="0" rIns="0" bIns="0" rtlCol="0" anchor="ctr">
+            <a:normAutofit/>
+          </a:bodyPr>
           <a:lstStyle/>
           <a:p>
             <a:pPr indent="0" marL="0">
               <a:buNone/>
             </a:pPr>
             <a:r>
-              <a:rPr lang="en-US" sz="2400" dirty="0">
+              <a:rPr lang="en-US" sz="1900" b="1" dirty="0">
+                <a:solidFill>
+                  <a:srgbClr val="1D1D1F"/>
+                </a:solidFill>
+              </a:rPr>
+              <a:t>Missing data</a:t>
+            </a:r>
+            <a:endParaRPr lang="en-US" sz="1900" dirty="0"/>
+          </a:p>
+        </p:txBody>
+      </p:sp>
+      <p:sp>
+        <p:nvSpPr>
+          <p:cNvPr id="19" name="Text 16"/>
+          <p:cNvSpPr txBox="1"/>
+          <p:nvPr/>
+        </p:nvSpPr>
+        <p:spPr>
+          <a:xfrm>
+            <a:off x="822960" y="5010912"/>
+            <a:ext cx="4861408" cy="1005840"/>
+          </a:xfrm>
+          <a:prstGeom prst="rect">
+            <a:avLst/>
+          </a:prstGeom>
+          <a:noFill/>
+          <a:ln/>
+        </p:spPr>
+        <p:txBody>
+          <a:bodyPr wrap="square" lIns="0" tIns="0" rIns="0" bIns="0" rtlCol="0" anchor="t"/>
+          <a:lstStyle/>
+          <a:p>
+            <a:pPr indent="0" marL="0">
+              <a:buNone/>
+            </a:pPr>
+            <a:r>
+              <a:rPr lang="en-US" sz="1500" dirty="0">
+                <a:solidFill>
+                  <a:srgbClr val="6E6E73"/>
+                </a:solidFill>
+              </a:rPr>
+              <a:t>Europa League before 2020-21, managers not yet included</a:t>
+            </a:r>
+            <a:endParaRPr lang="en-US" sz="1500" dirty="0"/>
+          </a:p>
+        </p:txBody>
+      </p:sp>
+      <p:sp>
+        <p:nvSpPr>
+          <p:cNvPr id="20" name="Card 4"/>
+          <p:cNvSpPr/>
+          <p:nvPr/>
+        </p:nvSpPr>
+        <p:spPr>
+          <a:xfrm>
+            <a:off x="6233008" y="4206240"/>
+            <a:ext cx="5410048" cy="1965960"/>
+          </a:xfrm>
+          <a:prstGeom prst="roundRect">
+            <a:avLst>
+              <a:gd name="adj" fmla="val 8372"/>
+            </a:avLst>
+          </a:prstGeom>
+          <a:solidFill>
+            <a:srgbClr val="FFFFFF"/>
+          </a:solidFill>
+          <a:ln w="12700">
+            <a:solidFill>
+              <a:srgbClr val="FFFFFF"/>
+            </a:solidFill>
+            <a:prstDash val="solid"/>
+          </a:ln>
+          <a:effectLst>
+            <a:outerShdw sx="100000" sy="100000" kx="0" ky="0" algn="bl" rotWithShape="0" blurRad="101600" dist="25400" dir="5400000">
+              <a:srgbClr val="000000">
+                <a:alpha val="8000"/>
+              </a:srgbClr>
+            </a:outerShdw>
+          </a:effectLst>
+        </p:spPr>
+      </p:sp>
+      <p:sp>
+        <p:nvSpPr>
+          <p:cNvPr id="21" name="Card 4 dot"/>
+          <p:cNvSpPr/>
+          <p:nvPr/>
+        </p:nvSpPr>
+        <p:spPr>
+          <a:xfrm>
+            <a:off x="6507328" y="4480560"/>
+            <a:ext cx="384048" cy="384048"/>
+          </a:xfrm>
+          <a:prstGeom prst="ellipse">
+            <a:avLst/>
+          </a:prstGeom>
+          <a:solidFill>
+            <a:srgbClr val="0071E3"/>
+          </a:solidFill>
+          <a:ln w="12700">
+            <a:solidFill>
+              <a:srgbClr val="0071E3"/>
+            </a:solidFill>
+            <a:prstDash val="solid"/>
+          </a:ln>
+        </p:spPr>
+      </p:sp>
+      <p:sp>
+        <p:nvSpPr>
+          <p:cNvPr id="22" name="Text 19"/>
+          <p:cNvSpPr txBox="1"/>
+          <p:nvPr/>
+        </p:nvSpPr>
+        <p:spPr>
+          <a:xfrm>
+            <a:off x="6507328" y="4480560"/>
+            <a:ext cx="384048" cy="384048"/>
+          </a:xfrm>
+          <a:prstGeom prst="rect">
+            <a:avLst/>
+          </a:prstGeom>
+          <a:noFill/>
+          <a:ln/>
+        </p:spPr>
+        <p:txBody>
+          <a:bodyPr wrap="square" lIns="0" tIns="0" rIns="0" bIns="0" rtlCol="0" anchor="ctr"/>
+          <a:lstStyle/>
+          <a:p>
+            <a:pPr algn="ctr" indent="0" marL="0">
+              <a:buNone/>
+            </a:pPr>
+            <a:r>
+              <a:rPr lang="en-US" sz="1400" b="1" dirty="0">
                 <a:solidFill>
                   <a:srgbClr val="FFFFFF"/>
                 </a:solidFill>
               </a:rPr>
-              <a:t>Testing properly matters more than a fancy model</a:t>
-            </a:r>
-            <a:endParaRPr lang="en-US" sz="2400" dirty="0"/>
+              <a:t>4</a:t>
+            </a:r>
+            <a:endParaRPr lang="en-US" sz="1400" dirty="0"/>
+          </a:p>
+        </p:txBody>
+      </p:sp>
+      <p:sp>
+        <p:nvSpPr>
+          <p:cNvPr id="23" name="Text 20"/>
+          <p:cNvSpPr txBox="1"/>
+          <p:nvPr/>
+        </p:nvSpPr>
+        <p:spPr>
+          <a:xfrm>
+            <a:off x="7055968" y="4443984"/>
+            <a:ext cx="4312768" cy="457200"/>
+          </a:xfrm>
+          <a:prstGeom prst="rect">
+            <a:avLst/>
+          </a:prstGeom>
+          <a:noFill/>
+          <a:ln/>
+        </p:spPr>
+        <p:txBody>
+          <a:bodyPr wrap="square" lIns="0" tIns="0" rIns="0" bIns="0" rtlCol="0" anchor="ctr">
+            <a:normAutofit/>
+          </a:bodyPr>
+          <a:lstStyle/>
+          <a:p>
+            <a:pPr indent="0" marL="0">
+              <a:buNone/>
+            </a:pPr>
+            <a:r>
+              <a:rPr lang="en-US" sz="1900" b="1" dirty="0">
+                <a:solidFill>
+                  <a:srgbClr val="1D1D1F"/>
+                </a:solidFill>
+              </a:rPr>
+              <a:t>Next steps</a:t>
+            </a:r>
+            <a:endParaRPr lang="en-US" sz="1900" dirty="0"/>
+          </a:p>
+        </p:txBody>
+      </p:sp>
+      <p:sp>
+        <p:nvSpPr>
+          <p:cNvPr id="24" name="Text 21"/>
+          <p:cNvSpPr txBox="1"/>
+          <p:nvPr/>
+        </p:nvSpPr>
+        <p:spPr>
+          <a:xfrm>
+            <a:off x="6507328" y="5010912"/>
+            <a:ext cx="4861408" cy="1005840"/>
+          </a:xfrm>
+          <a:prstGeom prst="rect">
+            <a:avLst/>
+          </a:prstGeom>
+          <a:noFill/>
+          <a:ln/>
+        </p:spPr>
+        <p:txBody>
+          <a:bodyPr wrap="square" lIns="0" tIns="0" rIns="0" bIns="0" rtlCol="0" anchor="t"/>
+          <a:lstStyle/>
+          <a:p>
+            <a:pPr indent="0" marL="0">
+              <a:buNone/>
+            </a:pPr>
+            <a:r>
+              <a:rPr lang="en-US" sz="1500" dirty="0">
+                <a:solidFill>
+                  <a:srgbClr val="6E6E73"/>
+                </a:solidFill>
+              </a:rPr>
+              <a:t>Expected goals (xG) data, simulating a whole season's table</a:t>
+            </a:r>
+            <a:endParaRPr lang="en-US" sz="1500" dirty="0"/>
           </a:p>
         </p:txBody>
       </p:sp>
@@ -11244,7 +11718,7 @@
             <a:lvl1pPr>
               <a:defRPr sz="1000">
                 <a:solidFill>
-                  <a:srgbClr val="A1A1A6"/>
+                  <a:srgbClr val="86868B"/>
                 </a:solidFill>
               </a:defRPr>
             </a:lvl1pPr>
@@ -11292,6 +11766,441 @@
         </p:nvSpPr>
         <p:spPr>
           <a:xfrm>
+            <a:off x="548640" y="822960"/>
+            <a:ext cx="11094415" cy="365760"/>
+          </a:xfrm>
+          <a:prstGeom prst="rect">
+            <a:avLst/>
+          </a:prstGeom>
+          <a:noFill/>
+          <a:ln/>
+        </p:spPr>
+        <p:txBody>
+          <a:bodyPr wrap="square" lIns="0" tIns="0" rIns="0" bIns="0" rtlCol="0" anchor="ctr"/>
+          <a:lstStyle/>
+          <a:p>
+            <a:pPr indent="0" marL="0">
+              <a:buNone/>
+            </a:pPr>
+            <a:r>
+              <a:rPr lang="en-US" sz="1600" b="1" dirty="0">
+                <a:solidFill>
+                  <a:srgbClr val="2997FF"/>
+                </a:solidFill>
+              </a:rPr>
+              <a:t>Conclusion</a:t>
+            </a:r>
+            <a:endParaRPr lang="en-US" sz="1600" dirty="0"/>
+          </a:p>
+        </p:txBody>
+      </p:sp>
+      <p:sp>
+        <p:nvSpPr>
+          <p:cNvPr id="4" name="Title"/>
+          <p:cNvSpPr txBox="1"/>
+          <p:nvPr/>
+        </p:nvSpPr>
+        <p:spPr>
+          <a:xfrm>
+            <a:off x="548640" y="1207008"/>
+            <a:ext cx="11094415" cy="868680"/>
+          </a:xfrm>
+          <a:prstGeom prst="rect">
+            <a:avLst/>
+          </a:prstGeom>
+          <a:noFill/>
+          <a:ln/>
+        </p:spPr>
+        <p:txBody>
+          <a:bodyPr wrap="square" lIns="0" tIns="0" rIns="0" bIns="0" rtlCol="0" anchor="t">
+            <a:normAutofit/>
+          </a:bodyPr>
+          <a:lstStyle/>
+          <a:p>
+            <a:pPr indent="0" marL="0">
+              <a:buNone/>
+            </a:pPr>
+            <a:r>
+              <a:rPr lang="en-US" sz="3600" b="1" dirty="0">
+                <a:solidFill>
+                  <a:srgbClr val="FFFFFF"/>
+                </a:solidFill>
+              </a:rPr>
+              <a:t>What we learned</a:t>
+            </a:r>
+            <a:endParaRPr lang="en-US" sz="3600" dirty="0"/>
+          </a:p>
+        </p:txBody>
+      </p:sp>
+      <p:sp>
+        <p:nvSpPr>
+          <p:cNvPr id="5" name="Number 1"/>
+          <p:cNvSpPr/>
+          <p:nvPr/>
+        </p:nvSpPr>
+        <p:spPr>
+          <a:xfrm>
+            <a:off x="548640" y="2377440"/>
+            <a:ext cx="548640" cy="548640"/>
+          </a:xfrm>
+          <a:prstGeom prst="ellipse">
+            <a:avLst/>
+          </a:prstGeom>
+          <a:solidFill>
+            <a:srgbClr val="2997FF"/>
+          </a:solidFill>
+          <a:ln w="12700">
+            <a:solidFill>
+              <a:srgbClr val="2997FF"/>
+            </a:solidFill>
+            <a:prstDash val="solid"/>
+          </a:ln>
+        </p:spPr>
+      </p:sp>
+      <p:sp>
+        <p:nvSpPr>
+          <p:cNvPr id="6" name="Text 3"/>
+          <p:cNvSpPr txBox="1"/>
+          <p:nvPr/>
+        </p:nvSpPr>
+        <p:spPr>
+          <a:xfrm>
+            <a:off x="548640" y="2377440"/>
+            <a:ext cx="548640" cy="548640"/>
+          </a:xfrm>
+          <a:prstGeom prst="rect">
+            <a:avLst/>
+          </a:prstGeom>
+          <a:noFill/>
+          <a:ln/>
+        </p:spPr>
+        <p:txBody>
+          <a:bodyPr wrap="square" lIns="0" tIns="0" rIns="0" bIns="0" rtlCol="0" anchor="ctr"/>
+          <a:lstStyle/>
+          <a:p>
+            <a:pPr algn="ctr" indent="0" marL="0">
+              <a:buNone/>
+            </a:pPr>
+            <a:r>
+              <a:rPr lang="en-US" sz="2000" b="1" dirty="0">
+                <a:solidFill>
+                  <a:srgbClr val="000000"/>
+                </a:solidFill>
+              </a:rPr>
+              <a:t>1</a:t>
+            </a:r>
+            <a:endParaRPr lang="en-US" sz="2000" dirty="0"/>
+          </a:p>
+        </p:txBody>
+      </p:sp>
+      <p:sp>
+        <p:nvSpPr>
+          <p:cNvPr id="7" name="Takeaway 1"/>
+          <p:cNvSpPr txBox="1"/>
+          <p:nvPr/>
+        </p:nvSpPr>
+        <p:spPr>
+          <a:xfrm>
+            <a:off x="1371600" y="2331720"/>
+            <a:ext cx="10271455" cy="640080"/>
+          </a:xfrm>
+          <a:prstGeom prst="rect">
+            <a:avLst/>
+          </a:prstGeom>
+          <a:noFill/>
+          <a:ln/>
+        </p:spPr>
+        <p:txBody>
+          <a:bodyPr wrap="square" lIns="0" tIns="0" rIns="0" bIns="0" rtlCol="0" anchor="ctr"/>
+          <a:lstStyle/>
+          <a:p>
+            <a:pPr indent="0" marL="0">
+              <a:buNone/>
+            </a:pPr>
+            <a:r>
+              <a:rPr lang="en-US" sz="2400" dirty="0">
+                <a:solidFill>
+                  <a:srgbClr val="FFFFFF"/>
+                </a:solidFill>
+              </a:rPr>
+              <a:t>A fair model reaches 53.6%, close to the bookmaker's 54.7%</a:t>
+            </a:r>
+            <a:endParaRPr lang="en-US" sz="2400" dirty="0"/>
+          </a:p>
+        </p:txBody>
+      </p:sp>
+      <p:sp>
+        <p:nvSpPr>
+          <p:cNvPr id="8" name="Number 2"/>
+          <p:cNvSpPr/>
+          <p:nvPr/>
+        </p:nvSpPr>
+        <p:spPr>
+          <a:xfrm>
+            <a:off x="548640" y="3520440"/>
+            <a:ext cx="548640" cy="548640"/>
+          </a:xfrm>
+          <a:prstGeom prst="ellipse">
+            <a:avLst/>
+          </a:prstGeom>
+          <a:solidFill>
+            <a:srgbClr val="2997FF"/>
+          </a:solidFill>
+          <a:ln w="12700">
+            <a:solidFill>
+              <a:srgbClr val="2997FF"/>
+            </a:solidFill>
+            <a:prstDash val="solid"/>
+          </a:ln>
+        </p:spPr>
+      </p:sp>
+      <p:sp>
+        <p:nvSpPr>
+          <p:cNvPr id="9" name="Text 6"/>
+          <p:cNvSpPr txBox="1"/>
+          <p:nvPr/>
+        </p:nvSpPr>
+        <p:spPr>
+          <a:xfrm>
+            <a:off x="548640" y="3520440"/>
+            <a:ext cx="548640" cy="548640"/>
+          </a:xfrm>
+          <a:prstGeom prst="rect">
+            <a:avLst/>
+          </a:prstGeom>
+          <a:noFill/>
+          <a:ln/>
+        </p:spPr>
+        <p:txBody>
+          <a:bodyPr wrap="square" lIns="0" tIns="0" rIns="0" bIns="0" rtlCol="0" anchor="ctr"/>
+          <a:lstStyle/>
+          <a:p>
+            <a:pPr algn="ctr" indent="0" marL="0">
+              <a:buNone/>
+            </a:pPr>
+            <a:r>
+              <a:rPr lang="en-US" sz="2000" b="1" dirty="0">
+                <a:solidFill>
+                  <a:srgbClr val="000000"/>
+                </a:solidFill>
+              </a:rPr>
+              <a:t>2</a:t>
+            </a:r>
+            <a:endParaRPr lang="en-US" sz="2000" dirty="0"/>
+          </a:p>
+        </p:txBody>
+      </p:sp>
+      <p:sp>
+        <p:nvSpPr>
+          <p:cNvPr id="10" name="Takeaway 2"/>
+          <p:cNvSpPr txBox="1"/>
+          <p:nvPr/>
+        </p:nvSpPr>
+        <p:spPr>
+          <a:xfrm>
+            <a:off x="1371600" y="3474720"/>
+            <a:ext cx="10271455" cy="640080"/>
+          </a:xfrm>
+          <a:prstGeom prst="rect">
+            <a:avLst/>
+          </a:prstGeom>
+          <a:noFill/>
+          <a:ln/>
+        </p:spPr>
+        <p:txBody>
+          <a:bodyPr wrap="square" lIns="0" tIns="0" rIns="0" bIns="0" rtlCol="0" anchor="ctr"/>
+          <a:lstStyle/>
+          <a:p>
+            <a:pPr indent="0" marL="0">
+              <a:buNone/>
+            </a:pPr>
+            <a:r>
+              <a:rPr lang="en-US" sz="2400" dirty="0">
+                <a:solidFill>
+                  <a:srgbClr val="FFFFFF"/>
+                </a:solidFill>
+              </a:rPr>
+              <a:t>Team strength (Elo) matters most; a simple Poisson model beat complex ones</a:t>
+            </a:r>
+            <a:endParaRPr lang="en-US" sz="2400" dirty="0"/>
+          </a:p>
+        </p:txBody>
+      </p:sp>
+      <p:sp>
+        <p:nvSpPr>
+          <p:cNvPr id="11" name="Number 3"/>
+          <p:cNvSpPr/>
+          <p:nvPr/>
+        </p:nvSpPr>
+        <p:spPr>
+          <a:xfrm>
+            <a:off x="548640" y="4663440"/>
+            <a:ext cx="548640" cy="548640"/>
+          </a:xfrm>
+          <a:prstGeom prst="ellipse">
+            <a:avLst/>
+          </a:prstGeom>
+          <a:solidFill>
+            <a:srgbClr val="2997FF"/>
+          </a:solidFill>
+          <a:ln w="12700">
+            <a:solidFill>
+              <a:srgbClr val="2997FF"/>
+            </a:solidFill>
+            <a:prstDash val="solid"/>
+          </a:ln>
+        </p:spPr>
+      </p:sp>
+      <p:sp>
+        <p:nvSpPr>
+          <p:cNvPr id="12" name="Text 9"/>
+          <p:cNvSpPr txBox="1"/>
+          <p:nvPr/>
+        </p:nvSpPr>
+        <p:spPr>
+          <a:xfrm>
+            <a:off x="548640" y="4663440"/>
+            <a:ext cx="548640" cy="548640"/>
+          </a:xfrm>
+          <a:prstGeom prst="rect">
+            <a:avLst/>
+          </a:prstGeom>
+          <a:noFill/>
+          <a:ln/>
+        </p:spPr>
+        <p:txBody>
+          <a:bodyPr wrap="square" lIns="0" tIns="0" rIns="0" bIns="0" rtlCol="0" anchor="ctr"/>
+          <a:lstStyle/>
+          <a:p>
+            <a:pPr algn="ctr" indent="0" marL="0">
+              <a:buNone/>
+            </a:pPr>
+            <a:r>
+              <a:rPr lang="en-US" sz="2000" b="1" dirty="0">
+                <a:solidFill>
+                  <a:srgbClr val="000000"/>
+                </a:solidFill>
+              </a:rPr>
+              <a:t>3</a:t>
+            </a:r>
+            <a:endParaRPr lang="en-US" sz="2000" dirty="0"/>
+          </a:p>
+        </p:txBody>
+      </p:sp>
+      <p:sp>
+        <p:nvSpPr>
+          <p:cNvPr id="13" name="Takeaway 3"/>
+          <p:cNvSpPr txBox="1"/>
+          <p:nvPr/>
+        </p:nvSpPr>
+        <p:spPr>
+          <a:xfrm>
+            <a:off x="1371600" y="4617720"/>
+            <a:ext cx="10271455" cy="640080"/>
+          </a:xfrm>
+          <a:prstGeom prst="rect">
+            <a:avLst/>
+          </a:prstGeom>
+          <a:noFill/>
+          <a:ln/>
+        </p:spPr>
+        <p:txBody>
+          <a:bodyPr wrap="square" lIns="0" tIns="0" rIns="0" bIns="0" rtlCol="0" anchor="ctr"/>
+          <a:lstStyle/>
+          <a:p>
+            <a:pPr indent="0" marL="0">
+              <a:buNone/>
+            </a:pPr>
+            <a:r>
+              <a:rPr lang="en-US" sz="2400" dirty="0">
+                <a:solidFill>
+                  <a:srgbClr val="FFFFFF"/>
+                </a:solidFill>
+              </a:rPr>
+              <a:t>Testing properly matters more than a fancy model</a:t>
+            </a:r>
+            <a:endParaRPr lang="en-US" sz="2400" dirty="0"/>
+          </a:p>
+        </p:txBody>
+      </p:sp>
+      <p:sp>
+        <p:nvSpPr>
+          <p:cNvPr id="25" name="Slide Number Placeholder 0"/>
+          <p:cNvSpPr>
+            <a:spLocks noGrp="1"/>
+          </p:cNvSpPr>
+          <p:nvPr>
+            <p:ph type="sldNum" sz="quarter" idx="4294967295"/>
+          </p:nvPr>
+        </p:nvSpPr>
+        <p:spPr>
+          <a:xfrm>
+            <a:off x="11094415" y="6446520"/>
+            <a:ext cx="548640" cy="274320"/>
+          </a:xfrm>
+          <a:prstGeom prst="rect">
+            <a:avLst/>
+          </a:prstGeom>
+          <a:extLst>
+            <a:ext uri="{C572A759-6A51-4108-AA02-DFA0A04FC94B}">
+              <ma14:wrappingTextBoxFlag xmlns:ma14="http://schemas.microsoft.com/office/mac/drawingml/2011/main" val="0"/>
+            </a:ext>
+          </a:extLst>
+        </p:spPr>
+        <p:txBody>
+          <a:bodyPr/>
+          <a:lstStyle>
+            <a:lvl1pPr>
+              <a:defRPr sz="1000">
+                <a:solidFill>
+                  <a:srgbClr val="A1A1A6"/>
+                </a:solidFill>
+              </a:defRPr>
+            </a:lvl1pPr>
+          </a:lstStyle>
+          <a:p>
+            <a:pPr algn="r"/>
+            <a:fld id="{F7021451-1387-4CA6-816F-3879F97B5CBC}" type="slidenum">
+              <a:rPr b="0" lang="en-US"/>
+              <a:t>18</a:t>
+            </a:fld>
+            <a:endParaRPr lang="en-US"/>
+          </a:p>
+        </p:txBody>
+      </p:sp>
+    </p:spTree>
+  </p:cSld>
+  <p:clrMapOvr>
+    <a:masterClrMapping/>
+  </p:clrMapOvr>
+</p:sld>
+</file>
+
+<file path=ppt/slides/slide19.xml><?xml version="1.0" encoding="utf-8"?>
+<p:sld xmlns:a="http://schemas.openxmlformats.org/drawingml/2006/main" xmlns:r="http://schemas.openxmlformats.org/officeDocument/2006/relationships" xmlns:p="http://schemas.openxmlformats.org/presentationml/2006/main">
+  <p:cSld name="Slide 19">
+    <p:spTree>
+      <p:nvGrpSpPr>
+        <p:cNvPr id="1" name=""/>
+        <p:cNvGrpSpPr/>
+        <p:nvPr/>
+      </p:nvGrpSpPr>
+      <p:grpSpPr>
+        <a:xfrm>
+          <a:off x="0" y="0"/>
+          <a:ext cx="0" cy="0"/>
+          <a:chOff x="0" y="0"/>
+          <a:chExt cx="0" cy="0"/>
+        </a:xfrm>
+      </p:grpSpPr>
+      <p:sp>
+        <p:nvSpPr>
+          <p:cNvPr id="3" name="Kicker"/>
+          <p:cNvSpPr txBox="1"/>
+          <p:nvPr/>
+        </p:nvSpPr>
+        <p:spPr>
+          <a:xfrm>
             <a:off x="548640" y="502920"/>
             <a:ext cx="11094415" cy="365760"/>
           </a:xfrm>
@@ -11601,7 +12510,7 @@
             <a:pPr algn="r"/>
             <a:fld id="{F7021451-1387-4CA6-816F-3879F97B5CBC}" type="slidenum">
               <a:rPr b="0" lang="en-US"/>
-              <a:t>18</a:t>
+              <a:t>19</a:t>
             </a:fld>
             <a:endParaRPr lang="en-US"/>
           </a:p>

</xml_diff>